<commit_message>
adds CMU research about AI assistance
</commit_message>
<xml_diff>
--- a/Intro Slides/Course Intro.pptx
+++ b/Intro Slides/Course Intro.pptx
@@ -5,7 +5,7 @@
     <p:sldMasterId id="2147483680" r:id="rId5"/>
   </p:sldMasterIdLst>
   <p:notesMasterIdLst>
-    <p:notesMasterId r:id="rId19"/>
+    <p:notesMasterId r:id="rId20"/>
   </p:notesMasterIdLst>
   <p:sldIdLst>
     <p:sldId id="256" r:id="rId6"/>
@@ -19,8 +19,9 @@
     <p:sldId id="260" r:id="rId14"/>
     <p:sldId id="262" r:id="rId15"/>
     <p:sldId id="263" r:id="rId16"/>
-    <p:sldId id="267" r:id="rId17"/>
-    <p:sldId id="269" r:id="rId18"/>
+    <p:sldId id="270" r:id="rId17"/>
+    <p:sldId id="267" r:id="rId18"/>
+    <p:sldId id="269" r:id="rId19"/>
   </p:sldIdLst>
   <p:sldSz cx="12192000" cy="6858000"/>
   <p:notesSz cx="6858000" cy="9144000"/>
@@ -209,7 +210,7 @@
           <a:p>
             <a:fld id="{691C588C-9717-44ED-B9A9-CBD9D1909AD4}" type="datetimeFigureOut">
               <a:rPr lang="en-US" smtClean="0"/>
-              <a:t>3/12/2026</a:t>
+              <a:t>24-Apr-26</a:t>
             </a:fld>
             <a:endParaRPr lang="en-US"/>
           </a:p>
@@ -476,6 +477,114 @@
 </p:notesMaster>
 </file>
 
+<file path=ppt/notesSlides/notesSlide1.xml><?xml version="1.0" encoding="utf-8"?>
+<p:notes xmlns:a="http://schemas.openxmlformats.org/drawingml/2006/main" xmlns:r="http://schemas.openxmlformats.org/officeDocument/2006/relationships" xmlns:p="http://schemas.openxmlformats.org/presentationml/2006/main">
+  <p:cSld>
+    <p:spTree>
+      <p:nvGrpSpPr>
+        <p:cNvPr id="1" name=""/>
+        <p:cNvGrpSpPr/>
+        <p:nvPr/>
+      </p:nvGrpSpPr>
+      <p:grpSpPr>
+        <a:xfrm>
+          <a:off x="0" y="0"/>
+          <a:ext cx="0" cy="0"/>
+          <a:chOff x="0" y="0"/>
+          <a:chExt cx="0" cy="0"/>
+        </a:xfrm>
+      </p:grpSpPr>
+      <p:sp>
+        <p:nvSpPr>
+          <p:cNvPr id="2" name="Slide Image Placeholder 1"/>
+          <p:cNvSpPr>
+            <a:spLocks noGrp="1" noRot="1" noChangeAspect="1"/>
+          </p:cNvSpPr>
+          <p:nvPr>
+            <p:ph type="sldImg"/>
+          </p:nvPr>
+        </p:nvSpPr>
+        <p:spPr/>
+      </p:sp>
+      <p:sp>
+        <p:nvSpPr>
+          <p:cNvPr id="3" name="Notes Placeholder 2"/>
+          <p:cNvSpPr>
+            <a:spLocks noGrp="1"/>
+          </p:cNvSpPr>
+          <p:nvPr>
+            <p:ph type="body" idx="1"/>
+          </p:nvPr>
+        </p:nvSpPr>
+        <p:spPr/>
+        <p:txBody>
+          <a:bodyPr/>
+          <a:lstStyle/>
+          <a:p>
+            <a:r>
+              <a:rPr lang="en-US" dirty="0"/>
+              <a:t>Fraction (math) problems</a:t>
+            </a:r>
+          </a:p>
+          <a:p>
+            <a:r>
+              <a:rPr lang="en-US" dirty="0"/>
+              <a:t>Over 500 participants</a:t>
+            </a:r>
+          </a:p>
+          <a:p>
+            <a:r>
+              <a:rPr lang="en-US" dirty="0"/>
+              <a:t>Significant differences in groups (ANOVA)</a:t>
+            </a:r>
+          </a:p>
+          <a:p>
+            <a:endParaRPr lang="en-US" dirty="0"/>
+          </a:p>
+          <a:p>
+            <a:r>
+              <a:rPr lang="en-US" dirty="0"/>
+              <a:t>https://arxiv.org/pdf/2604.04721</a:t>
+            </a:r>
+          </a:p>
+        </p:txBody>
+      </p:sp>
+      <p:sp>
+        <p:nvSpPr>
+          <p:cNvPr id="4" name="Slide Number Placeholder 3"/>
+          <p:cNvSpPr>
+            <a:spLocks noGrp="1"/>
+          </p:cNvSpPr>
+          <p:nvPr>
+            <p:ph type="sldNum" sz="quarter" idx="5"/>
+          </p:nvPr>
+        </p:nvSpPr>
+        <p:spPr/>
+        <p:txBody>
+          <a:bodyPr/>
+          <a:lstStyle/>
+          <a:p>
+            <a:fld id="{460BBBCE-FA44-432B-84B0-7537B159768C}" type="slidenum">
+              <a:rPr lang="en-US" smtClean="0"/>
+              <a:t>12</a:t>
+            </a:fld>
+            <a:endParaRPr lang="en-US"/>
+          </a:p>
+        </p:txBody>
+      </p:sp>
+    </p:spTree>
+    <p:extLst>
+      <p:ext uri="{BB962C8B-B14F-4D97-AF65-F5344CB8AC3E}">
+        <p14:creationId xmlns:p14="http://schemas.microsoft.com/office/powerpoint/2010/main" val="2104343569"/>
+      </p:ext>
+    </p:extLst>
+  </p:cSld>
+  <p:clrMapOvr>
+    <a:masterClrMapping/>
+  </p:clrMapOvr>
+</p:notes>
+</file>
+
 <file path=ppt/slideLayouts/slideLayout1.xml><?xml version="1.0" encoding="utf-8"?>
 <p:sldLayout xmlns:a="http://schemas.openxmlformats.org/drawingml/2006/main" xmlns:r="http://schemas.openxmlformats.org/officeDocument/2006/relationships" xmlns:p="http://schemas.openxmlformats.org/presentationml/2006/main" showMasterSp="0" preserve="1" userDrawn="1">
   <p:cSld name="Title Slide">
@@ -524,7 +633,7 @@
           <a:p>
             <a:fld id="{7A3E0868-4E26-4CDC-8A56-D70E2D8B12FE}" type="datetime3">
               <a:rPr lang="en-US" smtClean="0"/>
-              <a:t>12 March 2026</a:t>
+              <a:t>24 April 2026</a:t>
             </a:fld>
             <a:endParaRPr lang="en-US"/>
           </a:p>
@@ -3085,7 +3194,7 @@
           <a:p>
             <a:fld id="{A7B8021B-6105-4216-96FC-94348F216D0E}" type="datetime3">
               <a:rPr lang="en-US" smtClean="0"/>
-              <a:t>12 March 2026</a:t>
+              <a:t>24 April 2026</a:t>
             </a:fld>
             <a:endParaRPr lang="en-US"/>
           </a:p>
@@ -4782,7 +4891,7 @@
           <a:p>
             <a:fld id="{5D27CFAB-73E6-44A8-B862-B3306344E3F2}" type="datetime3">
               <a:rPr lang="en-US" smtClean="0"/>
-              <a:t>12 March 2026</a:t>
+              <a:t>24 April 2026</a:t>
             </a:fld>
             <a:endParaRPr lang="en-US"/>
           </a:p>
@@ -6572,7 +6681,7 @@
           <a:p>
             <a:fld id="{A9B2E784-A5F5-4301-881B-94AC8DBF9DED}" type="datetime3">
               <a:rPr lang="en-US" smtClean="0"/>
-              <a:t>12 March 2026</a:t>
+              <a:t>24 April 2026</a:t>
             </a:fld>
             <a:endParaRPr lang="en-US"/>
           </a:p>
@@ -6751,7 +6860,7 @@
           <a:p>
             <a:fld id="{18EAB3A5-9E92-4BB9-8F22-9632B4FBEDBA}" type="datetime3">
               <a:rPr lang="en-US" smtClean="0"/>
-              <a:t>12 March 2026</a:t>
+              <a:t>24 April 2026</a:t>
             </a:fld>
             <a:endParaRPr lang="en-US"/>
           </a:p>
@@ -6978,7 +7087,7 @@
           <a:p>
             <a:fld id="{40923810-5FB2-48C9-96CA-1DE2C4773142}" type="datetime3">
               <a:rPr lang="en-US" smtClean="0"/>
-              <a:t>12 March 2026</a:t>
+              <a:t>24 April 2026</a:t>
             </a:fld>
             <a:endParaRPr lang="en-US"/>
           </a:p>
@@ -7268,7 +7377,7 @@
           <a:p>
             <a:fld id="{E50EFF4B-86EB-42FB-93EA-7D8F9CB2466F}" type="datetime3">
               <a:rPr lang="en-US" smtClean="0"/>
-              <a:t>12 March 2026</a:t>
+              <a:t>24 April 2026</a:t>
             </a:fld>
             <a:endParaRPr lang="en-US"/>
           </a:p>
@@ -7880,7 +7989,7 @@
           <a:p>
             <a:fld id="{FB14FC24-E041-45E9-9A72-E5755A86890F}" type="datetime3">
               <a:rPr lang="en-US" smtClean="0"/>
-              <a:t>12 March 2026</a:t>
+              <a:t>24 April 2026</a:t>
             </a:fld>
             <a:endParaRPr lang="en-US"/>
           </a:p>
@@ -8740,7 +8849,7 @@
           <a:p>
             <a:fld id="{98A19125-94A7-4474-858C-FD9C4ABE9DDA}" type="datetime3">
               <a:rPr lang="en-US" smtClean="0"/>
-              <a:t>12 March 2026</a:t>
+              <a:t>24 April 2026</a:t>
             </a:fld>
             <a:endParaRPr lang="en-US"/>
           </a:p>
@@ -9843,7 +9952,7 @@
           <a:p>
             <a:fld id="{3BA0343D-C8D8-43CE-BB79-50DEA219DB07}" type="datetime3">
               <a:rPr lang="en-US" smtClean="0"/>
-              <a:t>12 March 2026</a:t>
+              <a:t>24 April 2026</a:t>
             </a:fld>
             <a:endParaRPr lang="en-US"/>
           </a:p>
@@ -10132,7 +10241,7 @@
           <a:p>
             <a:fld id="{453BD212-0B9F-4987-965F-AC83B2FC354F}" type="datetime3">
               <a:rPr lang="en-US" smtClean="0"/>
-              <a:t>12 March 2026</a:t>
+              <a:t>24 April 2026</a:t>
             </a:fld>
             <a:endParaRPr lang="en-US"/>
           </a:p>
@@ -10375,7 +10484,7 @@
           <a:p>
             <a:fld id="{6DDC931E-8CBE-4A3F-A034-9B6122C6DCDB}" type="datetime3">
               <a:rPr lang="en-US" smtClean="0"/>
-              <a:t>12 March 2026</a:t>
+              <a:t>24 April 2026</a:t>
             </a:fld>
             <a:endParaRPr lang="en-US"/>
           </a:p>
@@ -12141,7 +12250,7 @@
           <a:p>
             <a:fld id="{220AF9C2-5E8A-4308-AE6B-CA9B65007D0E}" type="datetime3">
               <a:rPr lang="en-US" smtClean="0"/>
-              <a:t>12 March 2026</a:t>
+              <a:t>24 April 2026</a:t>
             </a:fld>
             <a:endParaRPr lang="en-US"/>
           </a:p>
@@ -12454,7 +12563,7 @@
           <a:p>
             <a:fld id="{FF31E861-D2AF-431D-860B-DCF67C218052}" type="datetime3">
               <a:rPr lang="en-US" smtClean="0"/>
-              <a:t>12 March 2026</a:t>
+              <a:t>24 April 2026</a:t>
             </a:fld>
             <a:endParaRPr lang="en-US"/>
           </a:p>
@@ -12733,7 +12842,7 @@
           <a:p>
             <a:fld id="{D1DA25B2-AAF1-4C1F-AA38-12D5BFA7D4C8}" type="datetime3">
               <a:rPr lang="en-US" smtClean="0"/>
-              <a:t>12 March 2026</a:t>
+              <a:t>24 April 2026</a:t>
             </a:fld>
             <a:endParaRPr lang="en-US"/>
           </a:p>
@@ -13012,7 +13121,7 @@
           <a:p>
             <a:fld id="{A25C0F39-45D0-48E9-90B3-7FE8FCE561C8}" type="datetime3">
               <a:rPr lang="en-US" smtClean="0"/>
-              <a:t>12 March 2026</a:t>
+              <a:t>24 April 2026</a:t>
             </a:fld>
             <a:endParaRPr lang="en-US"/>
           </a:p>
@@ -13513,7 +13622,7 @@
           <a:p>
             <a:fld id="{9BAF1A3D-92FA-4F24-9781-74AFA516A230}" type="datetime3">
               <a:rPr lang="en-US" smtClean="0"/>
-              <a:t>12 March 2026</a:t>
+              <a:t>24 April 2026</a:t>
             </a:fld>
             <a:endParaRPr lang="en-US"/>
           </a:p>
@@ -13640,7 +13749,7 @@
           <a:p>
             <a:fld id="{5719C672-856D-4617-A693-8FE15749A9B7}" type="datetime3">
               <a:rPr lang="en-US" smtClean="0"/>
-              <a:t>12 March 2026</a:t>
+              <a:t>24 April 2026</a:t>
             </a:fld>
             <a:endParaRPr lang="en-US"/>
           </a:p>
@@ -13775,7 +13884,7 @@
           <a:p>
             <a:fld id="{5F6C764D-A39E-4C03-B161-E0BC66E8883B}" type="datetime3">
               <a:rPr lang="en-US" smtClean="0"/>
-              <a:t>12 March 2026</a:t>
+              <a:t>24 April 2026</a:t>
             </a:fld>
             <a:endParaRPr lang="en-US"/>
           </a:p>
@@ -14013,7 +14122,7 @@
           <a:p>
             <a:fld id="{6E3E33F9-20B7-4995-BE7D-165DBB597850}" type="datetime3">
               <a:rPr lang="en-US" smtClean="0"/>
-              <a:t>12 March 2026</a:t>
+              <a:t>24 April 2026</a:t>
             </a:fld>
             <a:endParaRPr lang="en-US"/>
           </a:p>
@@ -14126,7 +14235,7 @@
           <a:p>
             <a:fld id="{CD41C263-3501-4369-A962-62B6BF915CDE}" type="datetime3">
               <a:rPr lang="en-US" smtClean="0"/>
-              <a:t>12 March 2026</a:t>
+              <a:t>24 April 2026</a:t>
             </a:fld>
             <a:endParaRPr lang="en-US"/>
           </a:p>
@@ -14529,7 +14638,7 @@
           <a:p>
             <a:fld id="{B06F3EBE-B2E8-4992-9F00-9E4B44F057C0}" type="datetime3">
               <a:rPr lang="en-US" smtClean="0"/>
-              <a:t>12 March 2026</a:t>
+              <a:t>24 April 2026</a:t>
             </a:fld>
             <a:endParaRPr lang="en-US"/>
           </a:p>
@@ -14661,7 +14770,7 @@
           <a:p>
             <a:fld id="{D41656AB-D2E1-472E-8B95-0DF5C6E1D623}" type="datetime3">
               <a:rPr lang="en-US" smtClean="0"/>
-              <a:t>12 March 2026</a:t>
+              <a:t>24 April 2026</a:t>
             </a:fld>
             <a:endParaRPr lang="en-US"/>
           </a:p>
@@ -16522,7 +16631,7 @@
           <a:p>
             <a:fld id="{AD622D1A-DF83-41A8-85FF-04D90BF831D3}" type="datetime3">
               <a:rPr lang="en-US" smtClean="0"/>
-              <a:t>12 March 2026</a:t>
+              <a:t>24 April 2026</a:t>
             </a:fld>
             <a:endParaRPr lang="en-US"/>
           </a:p>
@@ -16772,7 +16881,7 @@
           <a:p>
             <a:fld id="{334F72C3-CDF3-44A8-B602-1649B1728485}" type="datetime3">
               <a:rPr lang="en-US" smtClean="0"/>
-              <a:t>12 March 2026</a:t>
+              <a:t>24 April 2026</a:t>
             </a:fld>
             <a:endParaRPr lang="en-US"/>
           </a:p>
@@ -17079,7 +17188,7 @@
           <a:p>
             <a:fld id="{1E0132BA-B5E7-4FFD-AF6C-169169D47D4A}" type="datetime3">
               <a:rPr lang="en-US" smtClean="0"/>
-              <a:t>12 March 2026</a:t>
+              <a:t>24 April 2026</a:t>
             </a:fld>
             <a:endParaRPr lang="en-US"/>
           </a:p>
@@ -17560,7 +17669,7 @@
           <a:p>
             <a:fld id="{81A30091-1C2A-4151-8D3C-D1E47A72615F}" type="datetime3">
               <a:rPr lang="en-US" smtClean="0"/>
-              <a:t>12 March 2026</a:t>
+              <a:t>24 April 2026</a:t>
             </a:fld>
             <a:endParaRPr lang="en-US"/>
           </a:p>
@@ -18197,7 +18306,7 @@
           <a:p>
             <a:fld id="{35D703CE-07B4-4C05-A488-B4566700621F}" type="datetime3">
               <a:rPr lang="en-US" smtClean="0"/>
-              <a:t>12 March 2026</a:t>
+              <a:t>24 April 2026</a:t>
             </a:fld>
             <a:endParaRPr lang="en-US"/>
           </a:p>
@@ -19255,7 +19364,7 @@
           <a:p>
             <a:fld id="{694BD61C-20BA-43AF-A21F-1DAFB3200099}" type="datetime3">
               <a:rPr lang="en-US" smtClean="0"/>
-              <a:t>12 March 2026</a:t>
+              <a:t>24 April 2026</a:t>
             </a:fld>
             <a:endParaRPr lang="en-US"/>
           </a:p>
@@ -19742,7 +19851,7 @@
           <a:p>
             <a:fld id="{CABCB1B0-B6E5-4DD1-BB55-95C076D6C0C8}" type="datetime3">
               <a:rPr lang="en-US" smtClean="0"/>
-              <a:t>12 March 2026</a:t>
+              <a:t>24 April 2026</a:t>
             </a:fld>
             <a:endParaRPr lang="en-US"/>
           </a:p>
@@ -20284,7 +20393,7 @@
           <a:p>
             <a:fld id="{7A3E0868-4E26-4CDC-8A56-D70E2D8B12FE}" type="datetime3">
               <a:rPr lang="en-US" smtClean="0"/>
-              <a:t>12 March 2026</a:t>
+              <a:t>24 April 2026</a:t>
             </a:fld>
             <a:endParaRPr lang="en-US"/>
           </a:p>
@@ -20849,7 +20958,7 @@
           <a:p>
             <a:fld id="{334F72C3-CDF3-44A8-B602-1649B1728485}" type="datetime3">
               <a:rPr lang="en-US" smtClean="0"/>
-              <a:t>12 March 2026</a:t>
+              <a:t>24 April 2026</a:t>
             </a:fld>
             <a:endParaRPr lang="en-US"/>
           </a:p>
@@ -21078,7 +21187,7 @@
           <a:p>
             <a:fld id="{334F72C3-CDF3-44A8-B602-1649B1728485}" type="datetime3">
               <a:rPr lang="en-US" smtClean="0"/>
-              <a:t>12 March 2026</a:t>
+              <a:t>24 April 2026</a:t>
             </a:fld>
             <a:endParaRPr lang="en-US"/>
           </a:p>
@@ -21146,10 +21255,10 @@
       </p:grpSpPr>
       <p:sp>
         <p:nvSpPr>
-          <p:cNvPr id="7" name="Title 6">
-            <a:extLst>
-              <a:ext uri="{FF2B5EF4-FFF2-40B4-BE49-F238E27FC236}">
-                <a16:creationId xmlns:a16="http://schemas.microsoft.com/office/drawing/2014/main" id="{A4D5FD76-351F-7FD4-F9C6-32F168AF4535}"/>
+          <p:cNvPr id="2" name="Title 1">
+            <a:extLst>
+              <a:ext uri="{FF2B5EF4-FFF2-40B4-BE49-F238E27FC236}">
+                <a16:creationId xmlns:a16="http://schemas.microsoft.com/office/drawing/2014/main" id="{BDF19F20-6347-584A-BCA2-BAE9AC8DADD7}"/>
               </a:ext>
             </a:extLst>
           </p:cNvPr>
@@ -21167,17 +21276,49 @@
           <a:p>
             <a:r>
               <a:rPr lang="en-US" dirty="0"/>
-              <a:t>Icebreaker - Human Bingo</a:t>
-            </a:r>
-          </a:p>
-        </p:txBody>
-      </p:sp>
+              <a:t>AI Assistance</a:t>
+            </a:r>
+          </a:p>
+        </p:txBody>
+      </p:sp>
+      <p:pic>
+        <p:nvPicPr>
+          <p:cNvPr id="18" name="Content Placeholder 17">
+            <a:extLst>
+              <a:ext uri="{FF2B5EF4-FFF2-40B4-BE49-F238E27FC236}">
+                <a16:creationId xmlns:a16="http://schemas.microsoft.com/office/drawing/2014/main" id="{8DC1FAFD-6C27-EB89-AF6C-D97D7CFBAE1F}"/>
+              </a:ext>
+            </a:extLst>
+          </p:cNvPr>
+          <p:cNvPicPr>
+            <a:picLocks noGrp="1" noChangeAspect="1"/>
+          </p:cNvPicPr>
+          <p:nvPr>
+            <p:ph sz="half" idx="2"/>
+          </p:nvPr>
+        </p:nvPicPr>
+        <p:blipFill>
+          <a:blip r:embed="rId3"/>
+          <a:stretch>
+            <a:fillRect/>
+          </a:stretch>
+        </p:blipFill>
+        <p:spPr>
+          <a:xfrm>
+            <a:off x="5713692" y="1600200"/>
+            <a:ext cx="6132482" cy="3126718"/>
+          </a:xfrm>
+          <a:prstGeom prst="rect">
+            <a:avLst/>
+          </a:prstGeom>
+        </p:spPr>
+      </p:pic>
       <p:sp>
         <p:nvSpPr>
           <p:cNvPr id="5" name="Date Placeholder 4">
             <a:extLst>
               <a:ext uri="{FF2B5EF4-FFF2-40B4-BE49-F238E27FC236}">
-                <a16:creationId xmlns:a16="http://schemas.microsoft.com/office/drawing/2014/main" id="{7AFD4283-DB82-2E73-7955-FBCA45E062FB}"/>
+                <a16:creationId xmlns:a16="http://schemas.microsoft.com/office/drawing/2014/main" id="{70532950-D79C-7986-0803-F6B857C67920}"/>
               </a:ext>
             </a:extLst>
           </p:cNvPr>
@@ -21195,7 +21336,7 @@
           <a:p>
             <a:fld id="{334F72C3-CDF3-44A8-B602-1649B1728485}" type="datetime3">
               <a:rPr lang="en-US" smtClean="0"/>
-              <a:t>12 March 2026</a:t>
+              <a:t>24 April 2026</a:t>
             </a:fld>
             <a:endParaRPr lang="en-US"/>
           </a:p>
@@ -21206,7 +21347,7 @@
           <p:cNvPr id="6" name="Slide Number Placeholder 5">
             <a:extLst>
               <a:ext uri="{FF2B5EF4-FFF2-40B4-BE49-F238E27FC236}">
-                <a16:creationId xmlns:a16="http://schemas.microsoft.com/office/drawing/2014/main" id="{8596F742-F0A4-7083-8E03-9A0A1148B690}"/>
+                <a16:creationId xmlns:a16="http://schemas.microsoft.com/office/drawing/2014/main" id="{76BE8291-E5F1-5171-CE44-034A6E101BEB}"/>
               </a:ext>
             </a:extLst>
           </p:cNvPr>
@@ -21226,6 +21367,341 @@
               <a:rPr lang="en-US" smtClean="0"/>
               <a:pPr/>
               <a:t>12</a:t>
+            </a:fld>
+            <a:endParaRPr lang="en-US"/>
+          </a:p>
+        </p:txBody>
+      </p:sp>
+      <p:pic>
+        <p:nvPicPr>
+          <p:cNvPr id="16" name="Content Placeholder 15">
+            <a:extLst>
+              <a:ext uri="{FF2B5EF4-FFF2-40B4-BE49-F238E27FC236}">
+                <a16:creationId xmlns:a16="http://schemas.microsoft.com/office/drawing/2014/main" id="{53C2F17F-325B-5CC6-C3B0-F07B7DD01C70}"/>
+              </a:ext>
+            </a:extLst>
+          </p:cNvPr>
+          <p:cNvPicPr>
+            <a:picLocks noGrp="1" noChangeAspect="1"/>
+          </p:cNvPicPr>
+          <p:nvPr>
+            <p:ph sz="half" idx="1"/>
+          </p:nvPr>
+        </p:nvPicPr>
+        <p:blipFill>
+          <a:blip r:embed="rId4"/>
+          <a:stretch>
+            <a:fillRect/>
+          </a:stretch>
+        </p:blipFill>
+        <p:spPr>
+          <a:xfrm>
+            <a:off x="945356" y="1600200"/>
+            <a:ext cx="4572000" cy="4572000"/>
+          </a:xfrm>
+          <a:prstGeom prst="rect">
+            <a:avLst/>
+          </a:prstGeom>
+        </p:spPr>
+      </p:pic>
+      <p:sp>
+        <p:nvSpPr>
+          <p:cNvPr id="19" name="TextBox 18">
+            <a:extLst>
+              <a:ext uri="{FF2B5EF4-FFF2-40B4-BE49-F238E27FC236}">
+                <a16:creationId xmlns:a16="http://schemas.microsoft.com/office/drawing/2014/main" id="{376BDAE6-F25C-FCF7-4ED5-5CBC3D4C1879}"/>
+              </a:ext>
+            </a:extLst>
+          </p:cNvPr>
+          <p:cNvSpPr txBox="1"/>
+          <p:nvPr/>
+        </p:nvSpPr>
+        <p:spPr>
+          <a:xfrm>
+            <a:off x="5620870" y="5011270"/>
+            <a:ext cx="6225303" cy="1160929"/>
+          </a:xfrm>
+          <a:prstGeom prst="rect">
+            <a:avLst/>
+          </a:prstGeom>
+          <a:noFill/>
+        </p:spPr>
+        <p:txBody>
+          <a:bodyPr wrap="none" lIns="0" tIns="0" rIns="0" bIns="0" rtlCol="0">
+            <a:noAutofit/>
+          </a:bodyPr>
+          <a:lstStyle/>
+          <a:p>
+            <a:pPr marL="182880" indent="-182880">
+              <a:lnSpc>
+                <a:spcPct val="95000"/>
+              </a:lnSpc>
+              <a:spcBef>
+                <a:spcPts val="1000"/>
+              </a:spcBef>
+              <a:buSzPct val="100000"/>
+              <a:buFont typeface="Arial"/>
+              <a:buChar char="▪"/>
+            </a:pPr>
+            <a:r>
+              <a:rPr lang="en-US" sz="1700" dirty="0"/>
+              <a:t>It’s not “don’t use AI”</a:t>
+            </a:r>
+          </a:p>
+          <a:p>
+            <a:pPr marL="182880" indent="-182880">
+              <a:lnSpc>
+                <a:spcPct val="95000"/>
+              </a:lnSpc>
+              <a:spcBef>
+                <a:spcPts val="1000"/>
+              </a:spcBef>
+              <a:buSzPct val="100000"/>
+              <a:buFont typeface="Arial"/>
+              <a:buChar char="▪"/>
+            </a:pPr>
+            <a:r>
+              <a:rPr lang="en-US" sz="1700" dirty="0"/>
+              <a:t>It’s “use AI intelligently”</a:t>
+            </a:r>
+          </a:p>
+        </p:txBody>
+      </p:sp>
+    </p:spTree>
+    <p:extLst>
+      <p:ext uri="{BB962C8B-B14F-4D97-AF65-F5344CB8AC3E}">
+        <p14:creationId xmlns:p14="http://schemas.microsoft.com/office/powerpoint/2010/main" val="578444504"/>
+      </p:ext>
+    </p:extLst>
+  </p:cSld>
+  <p:clrMapOvr>
+    <a:masterClrMapping/>
+  </p:clrMapOvr>
+  <p:timing>
+    <p:tnLst>
+      <p:par>
+        <p:cTn id="1" dur="indefinite" restart="never" nodeType="tmRoot">
+          <p:childTnLst>
+            <p:seq concurrent="1" nextAc="seek">
+              <p:cTn id="2" dur="indefinite" nodeType="mainSeq">
+                <p:childTnLst>
+                  <p:par>
+                    <p:cTn id="3" fill="hold">
+                      <p:stCondLst>
+                        <p:cond delay="indefinite"/>
+                      </p:stCondLst>
+                      <p:childTnLst>
+                        <p:par>
+                          <p:cTn id="4" fill="hold">
+                            <p:stCondLst>
+                              <p:cond delay="0"/>
+                            </p:stCondLst>
+                            <p:childTnLst>
+                              <p:par>
+                                <p:cTn id="5" presetID="1" presetClass="entr" presetSubtype="0" fill="hold" nodeType="clickEffect">
+                                  <p:stCondLst>
+                                    <p:cond delay="0"/>
+                                  </p:stCondLst>
+                                  <p:childTnLst>
+                                    <p:set>
+                                      <p:cBhvr>
+                                        <p:cTn id="6" dur="1" fill="hold">
+                                          <p:stCondLst>
+                                            <p:cond delay="0"/>
+                                          </p:stCondLst>
+                                        </p:cTn>
+                                        <p:tgtEl>
+                                          <p:spTgt spid="18"/>
+                                        </p:tgtEl>
+                                        <p:attrNameLst>
+                                          <p:attrName>style.visibility</p:attrName>
+                                        </p:attrNameLst>
+                                      </p:cBhvr>
+                                      <p:to>
+                                        <p:strVal val="visible"/>
+                                      </p:to>
+                                    </p:set>
+                                  </p:childTnLst>
+                                </p:cTn>
+                              </p:par>
+                            </p:childTnLst>
+                          </p:cTn>
+                        </p:par>
+                      </p:childTnLst>
+                    </p:cTn>
+                  </p:par>
+                  <p:par>
+                    <p:cTn id="7" fill="hold">
+                      <p:stCondLst>
+                        <p:cond delay="indefinite"/>
+                      </p:stCondLst>
+                      <p:childTnLst>
+                        <p:par>
+                          <p:cTn id="8" fill="hold">
+                            <p:stCondLst>
+                              <p:cond delay="0"/>
+                            </p:stCondLst>
+                            <p:childTnLst>
+                              <p:par>
+                                <p:cTn id="9" presetID="1" presetClass="entr" presetSubtype="0" fill="hold" grpId="0" nodeType="clickEffect">
+                                  <p:stCondLst>
+                                    <p:cond delay="0"/>
+                                  </p:stCondLst>
+                                  <p:childTnLst>
+                                    <p:set>
+                                      <p:cBhvr>
+                                        <p:cTn id="10" dur="1" fill="hold">
+                                          <p:stCondLst>
+                                            <p:cond delay="0"/>
+                                          </p:stCondLst>
+                                        </p:cTn>
+                                        <p:tgtEl>
+                                          <p:spTgt spid="19"/>
+                                        </p:tgtEl>
+                                        <p:attrNameLst>
+                                          <p:attrName>style.visibility</p:attrName>
+                                        </p:attrNameLst>
+                                      </p:cBhvr>
+                                      <p:to>
+                                        <p:strVal val="visible"/>
+                                      </p:to>
+                                    </p:set>
+                                  </p:childTnLst>
+                                </p:cTn>
+                              </p:par>
+                            </p:childTnLst>
+                          </p:cTn>
+                        </p:par>
+                      </p:childTnLst>
+                    </p:cTn>
+                  </p:par>
+                </p:childTnLst>
+              </p:cTn>
+              <p:prevCondLst>
+                <p:cond evt="onPrev" delay="0">
+                  <p:tgtEl>
+                    <p:sldTgt/>
+                  </p:tgtEl>
+                </p:cond>
+              </p:prevCondLst>
+              <p:nextCondLst>
+                <p:cond evt="onNext" delay="0">
+                  <p:tgtEl>
+                    <p:sldTgt/>
+                  </p:tgtEl>
+                </p:cond>
+              </p:nextCondLst>
+            </p:seq>
+          </p:childTnLst>
+        </p:cTn>
+      </p:par>
+    </p:tnLst>
+    <p:bldLst>
+      <p:bldP spid="19" grpId="0"/>
+    </p:bldLst>
+  </p:timing>
+</p:sld>
+</file>
+
+<file path=ppt/slides/slide13.xml><?xml version="1.0" encoding="utf-8"?>
+<p:sld xmlns:a="http://schemas.openxmlformats.org/drawingml/2006/main" xmlns:r="http://schemas.openxmlformats.org/officeDocument/2006/relationships" xmlns:p="http://schemas.openxmlformats.org/presentationml/2006/main">
+  <p:cSld>
+    <p:spTree>
+      <p:nvGrpSpPr>
+        <p:cNvPr id="1" name=""/>
+        <p:cNvGrpSpPr/>
+        <p:nvPr/>
+      </p:nvGrpSpPr>
+      <p:grpSpPr>
+        <a:xfrm>
+          <a:off x="0" y="0"/>
+          <a:ext cx="0" cy="0"/>
+          <a:chOff x="0" y="0"/>
+          <a:chExt cx="0" cy="0"/>
+        </a:xfrm>
+      </p:grpSpPr>
+      <p:sp>
+        <p:nvSpPr>
+          <p:cNvPr id="7" name="Title 6">
+            <a:extLst>
+              <a:ext uri="{FF2B5EF4-FFF2-40B4-BE49-F238E27FC236}">
+                <a16:creationId xmlns:a16="http://schemas.microsoft.com/office/drawing/2014/main" id="{A4D5FD76-351F-7FD4-F9C6-32F168AF4535}"/>
+              </a:ext>
+            </a:extLst>
+          </p:cNvPr>
+          <p:cNvSpPr>
+            <a:spLocks noGrp="1"/>
+          </p:cNvSpPr>
+          <p:nvPr>
+            <p:ph type="title"/>
+          </p:nvPr>
+        </p:nvSpPr>
+        <p:spPr/>
+        <p:txBody>
+          <a:bodyPr/>
+          <a:lstStyle/>
+          <a:p>
+            <a:r>
+              <a:rPr lang="en-US" dirty="0"/>
+              <a:t>Icebreaker - Human Bingo</a:t>
+            </a:r>
+          </a:p>
+        </p:txBody>
+      </p:sp>
+      <p:sp>
+        <p:nvSpPr>
+          <p:cNvPr id="5" name="Date Placeholder 4">
+            <a:extLst>
+              <a:ext uri="{FF2B5EF4-FFF2-40B4-BE49-F238E27FC236}">
+                <a16:creationId xmlns:a16="http://schemas.microsoft.com/office/drawing/2014/main" id="{7AFD4283-DB82-2E73-7955-FBCA45E062FB}"/>
+              </a:ext>
+            </a:extLst>
+          </p:cNvPr>
+          <p:cNvSpPr>
+            <a:spLocks noGrp="1"/>
+          </p:cNvSpPr>
+          <p:nvPr>
+            <p:ph type="dt" sz="half" idx="10"/>
+          </p:nvPr>
+        </p:nvSpPr>
+        <p:spPr/>
+        <p:txBody>
+          <a:bodyPr/>
+          <a:lstStyle/>
+          <a:p>
+            <a:fld id="{334F72C3-CDF3-44A8-B602-1649B1728485}" type="datetime3">
+              <a:rPr lang="en-US" smtClean="0"/>
+              <a:t>24 April 2026</a:t>
+            </a:fld>
+            <a:endParaRPr lang="en-US"/>
+          </a:p>
+        </p:txBody>
+      </p:sp>
+      <p:sp>
+        <p:nvSpPr>
+          <p:cNvPr id="6" name="Slide Number Placeholder 5">
+            <a:extLst>
+              <a:ext uri="{FF2B5EF4-FFF2-40B4-BE49-F238E27FC236}">
+                <a16:creationId xmlns:a16="http://schemas.microsoft.com/office/drawing/2014/main" id="{8596F742-F0A4-7083-8E03-9A0A1148B690}"/>
+              </a:ext>
+            </a:extLst>
+          </p:cNvPr>
+          <p:cNvSpPr>
+            <a:spLocks noGrp="1"/>
+          </p:cNvSpPr>
+          <p:nvPr>
+            <p:ph type="sldNum" sz="quarter" idx="11"/>
+          </p:nvPr>
+        </p:nvSpPr>
+        <p:spPr/>
+        <p:txBody>
+          <a:bodyPr/>
+          <a:lstStyle/>
+          <a:p>
+            <a:fld id="{64E5BE4B-2FBF-4174-9E62-85FAD1CB43A6}" type="slidenum">
+              <a:rPr lang="en-US" smtClean="0"/>
+              <a:pPr/>
+              <a:t>13</a:t>
             </a:fld>
             <a:endParaRPr lang="en-US"/>
           </a:p>
@@ -21277,7 +21753,7 @@
 </p:sld>
 </file>
 
-<file path=ppt/slides/slide13.xml><?xml version="1.0" encoding="utf-8"?>
+<file path=ppt/slides/slide14.xml><?xml version="1.0" encoding="utf-8"?>
 <p:sld xmlns:a="http://schemas.openxmlformats.org/drawingml/2006/main" xmlns:r="http://schemas.openxmlformats.org/officeDocument/2006/relationships" xmlns:p="http://schemas.openxmlformats.org/presentationml/2006/main">
   <p:cSld>
     <p:spTree>
@@ -21351,7 +21827,7 @@
           <a:p>
             <a:fld id="{AD622D1A-DF83-41A8-85FF-04D90BF831D3}" type="datetime3">
               <a:rPr lang="en-US" smtClean="0"/>
-              <a:t>12 March 2026</a:t>
+              <a:t>24 April 2026</a:t>
             </a:fld>
             <a:endParaRPr lang="en-US"/>
           </a:p>
@@ -21381,7 +21857,7 @@
             <a:fld id="{64E5BE4B-2FBF-4174-9E62-85FAD1CB43A6}" type="slidenum">
               <a:rPr lang="en-US" smtClean="0"/>
               <a:pPr/>
-              <a:t>13</a:t>
+              <a:t>14</a:t>
             </a:fld>
             <a:endParaRPr lang="en-US"/>
           </a:p>
@@ -21505,7 +21981,7 @@
           <a:p>
             <a:fld id="{AD622D1A-DF83-41A8-85FF-04D90BF831D3}" type="datetime3">
               <a:rPr lang="en-US" smtClean="0"/>
-              <a:t>12 March 2026</a:t>
+              <a:t>24 April 2026</a:t>
             </a:fld>
             <a:endParaRPr lang="en-US"/>
           </a:p>
@@ -21662,7 +22138,7 @@
           <a:p>
             <a:fld id="{6DDC931E-8CBE-4A3F-A034-9B6122C6DCDB}" type="datetime3">
               <a:rPr lang="en-US" smtClean="0"/>
-              <a:t>12 March 2026</a:t>
+              <a:t>24 April 2026</a:t>
             </a:fld>
             <a:endParaRPr lang="en-US"/>
           </a:p>
@@ -21811,7 +22287,7 @@
           <a:p>
             <a:fld id="{334F72C3-CDF3-44A8-B602-1649B1728485}" type="datetime3">
               <a:rPr lang="en-US" smtClean="0"/>
-              <a:t>12 March 2026</a:t>
+              <a:t>24 April 2026</a:t>
             </a:fld>
             <a:endParaRPr lang="en-US"/>
           </a:p>
@@ -21978,7 +22454,7 @@
           <a:p>
             <a:fld id="{334F72C3-CDF3-44A8-B602-1649B1728485}" type="datetime3">
               <a:rPr lang="en-US" smtClean="0"/>
-              <a:t>12 March 2026</a:t>
+              <a:t>24 April 2026</a:t>
             </a:fld>
             <a:endParaRPr lang="en-US"/>
           </a:p>
@@ -22145,7 +22621,7 @@
           <a:p>
             <a:fld id="{334F72C3-CDF3-44A8-B602-1649B1728485}" type="datetime3">
               <a:rPr lang="en-US" smtClean="0"/>
-              <a:t>12 March 2026</a:t>
+              <a:t>24 April 2026</a:t>
             </a:fld>
             <a:endParaRPr lang="en-US"/>
           </a:p>
@@ -22294,7 +22770,7 @@
           <a:p>
             <a:fld id="{334F72C3-CDF3-44A8-B602-1649B1728485}" type="datetime3">
               <a:rPr lang="en-US" smtClean="0"/>
-              <a:t>12 March 2026</a:t>
+              <a:t>24 April 2026</a:t>
             </a:fld>
             <a:endParaRPr lang="en-US"/>
           </a:p>
@@ -22473,7 +22949,7 @@
           <a:p>
             <a:fld id="{AD622D1A-DF83-41A8-85FF-04D90BF831D3}" type="datetime3">
               <a:rPr lang="en-US" smtClean="0"/>
-              <a:t>12 March 2026</a:t>
+              <a:t>24 April 2026</a:t>
             </a:fld>
             <a:endParaRPr lang="en-US"/>
           </a:p>
@@ -22640,7 +23116,7 @@
           <a:p>
             <a:fld id="{334F72C3-CDF3-44A8-B602-1649B1728485}" type="datetime3">
               <a:rPr lang="en-US" smtClean="0"/>
-              <a:t>12 March 2026</a:t>
+              <a:t>24 April 2026</a:t>
             </a:fld>
             <a:endParaRPr lang="en-US"/>
           </a:p>
@@ -23245,187 +23721,6 @@
 </file>
 
 <file path=customXml/item1.xml><?xml version="1.0" encoding="utf-8"?>
-<p:properties xmlns:p="http://schemas.microsoft.com/office/2006/metadata/properties" xmlns:xsi="http://www.w3.org/2001/XMLSchema-instance" xmlns:pc="http://schemas.microsoft.com/office/infopath/2007/PartnerControls">
-  <documentManagement>
-    <Name_x0028_Outlook_x0029_ xmlns="819a213c-e595-4af7-868c-5311d0f07b09">
-      <UserInfo>
-        <DisplayName/>
-        <AccountId xsi:nil="true"/>
-        <AccountType/>
-      </UserInfo>
-    </Name_x0028_Outlook_x0029_>
-    <_ip_UnifiedCompliancePolicyUIAction xmlns="http://schemas.microsoft.com/sharepoint/v3" xsi:nil="true"/>
-    <TaxCatchAll xmlns="43c4306d-bcae-48a3-b5b4-6245fba36c72">
-      <Value>117</Value>
-      <Value>336</Value>
-      <Value>352</Value>
-      <Value>332</Value>
-      <Value>330</Value>
-      <Value>5</Value>
-      <Value>88</Value>
-      <Value>2</Value>
-      <Value>1</Value>
-    </TaxCatchAll>
-    <Project xmlns="819a213c-e595-4af7-868c-5311d0f07b09">Shrike</Project>
-    <b3e0283348f04d719dc2db6c1ad0eab0 xmlns="819a213c-e595-4af7-868c-5311d0f07b09">
-      <Terms xmlns="http://schemas.microsoft.com/office/infopath/2007/PartnerControls"/>
-    </b3e0283348f04d719dc2db6c1ad0eab0>
-    <kf4578e6b9744d06891b013fb9171991 xmlns="819a213c-e595-4af7-868c-5311d0f07b09">
-      <Terms xmlns="http://schemas.microsoft.com/office/infopath/2007/PartnerControls">
-        <TermInfo xmlns="http://schemas.microsoft.com/office/infopath/2007/PartnerControls">
-          <TermName xmlns="http://schemas.microsoft.com/office/infopath/2007/PartnerControls">FCAI</TermName>
-          <TermId xmlns="http://schemas.microsoft.com/office/infopath/2007/PartnerControls">fd9e9f27-4afa-4bd6-9815-b72522a6dee4</TermId>
-        </TermInfo>
-      </Terms>
-    </kf4578e6b9744d06891b013fb9171991>
-    <e7bf107ab2e246c2ae3b25ccb19c4fe7 xmlns="819a213c-e595-4af7-868c-5311d0f07b09">
-      <Terms xmlns="http://schemas.microsoft.com/office/infopath/2007/PartnerControls"/>
-    </e7bf107ab2e246c2ae3b25ccb19c4fe7>
-    <Status xmlns="819a213c-e595-4af7-868c-5311d0f07b09">NA</Status>
-    <k1cd0d7a50e348e5b2cecacdbb53a3ff xmlns="819a213c-e595-4af7-868c-5311d0f07b09">
-      <Terms xmlns="http://schemas.microsoft.com/office/infopath/2007/PartnerControls">
-        <TermInfo xmlns="http://schemas.microsoft.com/office/infopath/2007/PartnerControls">
-          <TermName xmlns="http://schemas.microsoft.com/office/infopath/2007/PartnerControls">NA</TermName>
-          <TermId xmlns="http://schemas.microsoft.com/office/infopath/2007/PartnerControls">6c779868-fdfe-4433-a583-74f72965e832</TermId>
-        </TermInfo>
-      </Terms>
-    </k1cd0d7a50e348e5b2cecacdbb53a3ff>
-    <k4bd3d618c344bb496a0035fa1bfa95e xmlns="819a213c-e595-4af7-868c-5311d0f07b09">
-      <Terms xmlns="http://schemas.microsoft.com/office/infopath/2007/PartnerControls">
-        <TermInfo xmlns="http://schemas.microsoft.com/office/infopath/2007/PartnerControls">
-          <TermName xmlns="http://schemas.microsoft.com/office/infopath/2007/PartnerControls">NA</TermName>
-          <TermId xmlns="http://schemas.microsoft.com/office/infopath/2007/PartnerControls">14e9068e-14f9-49cc-a753-38a742264b27</TermId>
-        </TermInfo>
-      </Terms>
-    </k4bd3d618c344bb496a0035fa1bfa95e>
-    <m3911d227d12438196938f21bccbb829 xmlns="819a213c-e595-4af7-868c-5311d0f07b09">
-      <Terms xmlns="http://schemas.microsoft.com/office/infopath/2007/PartnerControls">
-        <TermInfo xmlns="http://schemas.microsoft.com/office/infopath/2007/PartnerControls">
-          <TermName xmlns="http://schemas.microsoft.com/office/infopath/2007/PartnerControls">Unclassified</TermName>
-          <TermId xmlns="http://schemas.microsoft.com/office/infopath/2007/PartnerControls">0e44ab2e-9e75-4d69-bacf-b9adbba64961</TermId>
-        </TermInfo>
-      </Terms>
-    </m3911d227d12438196938f21bccbb829>
-    <j85403ed819e4ad59bb8aa44734c7278 xmlns="819a213c-e595-4af7-868c-5311d0f07b09">
-      <Terms xmlns="http://schemas.microsoft.com/office/infopath/2007/PartnerControls">
-        <TermInfo xmlns="http://schemas.microsoft.com/office/infopath/2007/PartnerControls">
-          <TermName xmlns="http://schemas.microsoft.com/office/infopath/2007/PartnerControls">NA</TermName>
-          <TermId xmlns="http://schemas.microsoft.com/office/infopath/2007/PartnerControls">c413e2e5-7da6-4fb4-9318-c07a4c95104c</TermId>
-        </TermInfo>
-      </Terms>
-    </j85403ed819e4ad59bb8aa44734c7278>
-    <e41571422c3345b4bda9d3ac979b0442 xmlns="819a213c-e595-4af7-868c-5311d0f07b09">
-      <Terms xmlns="http://schemas.microsoft.com/office/infopath/2007/PartnerControls">
-        <TermInfo xmlns="http://schemas.microsoft.com/office/infopath/2007/PartnerControls">
-          <TermName xmlns="http://schemas.microsoft.com/office/infopath/2007/PartnerControls">Destroy</TermName>
-          <TermId xmlns="http://schemas.microsoft.com/office/infopath/2007/PartnerControls">81460359-14dd-47b4-9102-5fada66d1614</TermId>
-        </TermInfo>
-      </Terms>
-    </e41571422c3345b4bda9d3ac979b0442>
-    <b2c7cbb6fa064dd095a8ebf73878e15c xmlns="819a213c-e595-4af7-868c-5311d0f07b09">
-      <Terms xmlns="http://schemas.microsoft.com/office/infopath/2007/PartnerControls">
-        <TermInfo xmlns="http://schemas.microsoft.com/office/infopath/2007/PartnerControls">
-          <TermName xmlns="http://schemas.microsoft.com/office/infopath/2007/PartnerControls">D</TermName>
-          <TermId xmlns="http://schemas.microsoft.com/office/infopath/2007/PartnerControls">e66b2925-d207-445d-a7ac-7bf5587a61c3</TermId>
-        </TermInfo>
-      </Terms>
-    </b2c7cbb6fa064dd095a8ebf73878e15c>
-    <n050dff107b041e7a8136cabb03c9f16 xmlns="819a213c-e595-4af7-868c-5311d0f07b09">
-      <Terms xmlns="http://schemas.microsoft.com/office/infopath/2007/PartnerControls"/>
-    </n050dff107b041e7a8136cabb03c9f16>
-    <dbcc5996da9743a2aff52ccb96daf316 xmlns="819a213c-e595-4af7-868c-5311d0f07b09">
-      <Terms xmlns="http://schemas.microsoft.com/office/infopath/2007/PartnerControls"/>
-    </dbcc5996da9743a2aff52ccb96daf316>
-    <_ip_UnifiedCompliancePolicyProperties xmlns="http://schemas.microsoft.com/sharepoint/v3" xsi:nil="true"/>
-    <Comments xmlns="819a213c-e595-4af7-868c-5311d0f07b09" xsi:nil="true"/>
-    <_dlc_DocIdPersistId xmlns="43c4306d-bcae-48a3-b5b4-6245fba36c72" xsi:nil="true"/>
-    <_dlc_DocIdUrl xmlns="43c4306d-bcae-48a3-b5b4-6245fba36c72">
-      <Url>https://armyeitaas.sharepoint-mil.us/teams/AI2CKMDevelopmentTeam/_layouts/15/DocIdRedir.aspx?ID=PNCAVZZWCJMJ-719779062-26496</Url>
-      <Description>PNCAVZZWCJMJ-719779062-26496</Description>
-    </_dlc_DocIdUrl>
-    <Teams xmlns="819a213c-e595-4af7-868c-5311d0f07b09">NA</Teams>
-    <lcf76f155ced4ddcb4097134ff3c332f xmlns="819a213c-e595-4af7-868c-5311d0f07b09">
-      <Terms xmlns="http://schemas.microsoft.com/office/infopath/2007/PartnerControls"/>
-    </lcf76f155ced4ddcb4097134ff3c332f>
-    <kf187aa08ef840c0be306c2b7cf181cc xmlns="819a213c-e595-4af7-868c-5311d0f07b09">
-      <Terms xmlns="http://schemas.microsoft.com/office/infopath/2007/PartnerControls"/>
-    </kf187aa08ef840c0be306c2b7cf181cc>
-    <k8ed72fc0ac74230bc2bce9a30aa3ff1 xmlns="819a213c-e595-4af7-868c-5311d0f07b09">
-      <Terms xmlns="http://schemas.microsoft.com/office/infopath/2007/PartnerControls"/>
-    </k8ed72fc0ac74230bc2bce9a30aa3ff1>
-    <j3cec2dc15da4ea9ae4c2914aab734b8 xmlns="819a213c-e595-4af7-868c-5311d0f07b09">
-      <Terms xmlns="http://schemas.microsoft.com/office/infopath/2007/PartnerControls">
-        <TermInfo xmlns="http://schemas.microsoft.com/office/infopath/2007/PartnerControls">
-          <TermName xmlns="http://schemas.microsoft.com/office/infopath/2007/PartnerControls">Unofficial</TermName>
-          <TermId xmlns="http://schemas.microsoft.com/office/infopath/2007/PartnerControls">fb72a3e1-cd07-4e90-8aa1-1e35bcf7448f</TermId>
-        </TermInfo>
-      </Terms>
-    </j3cec2dc15da4ea9ae4c2914aab734b8>
-    <_dlc_DocId xmlns="43c4306d-bcae-48a3-b5b4-6245fba36c72">PNCAVZZWCJMJ-719779062-26496</_dlc_DocId>
-  </documentManagement>
-</p:properties>
-</file>
-
-<file path=customXml/item2.xml><?xml version="1.0" encoding="utf-8"?>
-<?mso-contentType ?>
-<FormTemplates xmlns="http://schemas.microsoft.com/sharepoint/v3/contenttype/forms">
-  <Display>DocumentLibraryForm</Display>
-  <Edit>DocumentLibraryForm</Edit>
-  <New>DocumentLibraryForm</New>
-</FormTemplates>
-</file>
-
-<file path=customXml/item3.xml><?xml version="1.0" encoding="utf-8"?>
-<?mso-contentType ?>
-<spe:Receivers xmlns:spe="http://schemas.microsoft.com/sharepoint/events">
-  <Receiver>
-    <Name>Document ID Generator</Name>
-    <Synchronization>Synchronous</Synchronization>
-    <Type>10001</Type>
-    <SequenceNumber>1000</SequenceNumber>
-    <Url/>
-    <Assembly>Microsoft.Office.DocumentManagement, Version=16.0.0.0, Culture=neutral, PublicKeyToken=71e9bce111e9429c</Assembly>
-    <Class>Microsoft.Office.DocumentManagement.Internal.DocIdHandler</Class>
-    <Data/>
-    <Filter/>
-  </Receiver>
-  <Receiver>
-    <Name>Document ID Generator</Name>
-    <Synchronization>Synchronous</Synchronization>
-    <Type>10002</Type>
-    <SequenceNumber>1001</SequenceNumber>
-    <Url/>
-    <Assembly>Microsoft.Office.DocumentManagement, Version=16.0.0.0, Culture=neutral, PublicKeyToken=71e9bce111e9429c</Assembly>
-    <Class>Microsoft.Office.DocumentManagement.Internal.DocIdHandler</Class>
-    <Data/>
-    <Filter/>
-  </Receiver>
-  <Receiver>
-    <Name>Document ID Generator</Name>
-    <Synchronization>Synchronous</Synchronization>
-    <Type>10004</Type>
-    <SequenceNumber>1002</SequenceNumber>
-    <Url/>
-    <Assembly>Microsoft.Office.DocumentManagement, Version=16.0.0.0, Culture=neutral, PublicKeyToken=71e9bce111e9429c</Assembly>
-    <Class>Microsoft.Office.DocumentManagement.Internal.DocIdHandler</Class>
-    <Data/>
-    <Filter/>
-  </Receiver>
-  <Receiver>
-    <Name>Document ID Generator</Name>
-    <Synchronization>Synchronous</Synchronization>
-    <Type>10006</Type>
-    <SequenceNumber>1003</SequenceNumber>
-    <Url/>
-    <Assembly>Microsoft.Office.DocumentManagement, Version=16.0.0.0, Culture=neutral, PublicKeyToken=71e9bce111e9429c</Assembly>
-    <Class>Microsoft.Office.DocumentManagement.Internal.DocIdHandler</Class>
-    <Data/>
-    <Filter/>
-  </Receiver>
-</spe:Receivers>
-</file>
-
-<file path=customXml/item4.xml><?xml version="1.0" encoding="utf-8"?>
 <ct:contentTypeSchema xmlns:ct="http://schemas.microsoft.com/office/2006/metadata/contentType" xmlns:ma="http://schemas.microsoft.com/office/2006/metadata/properties/metaAttributes" ct:_="" ma:_="" ma:contentTypeName="Document" ma:contentTypeID="0x010100744FEF590B341F46AAAF568C3B82DA74" ma:contentTypeVersion="126" ma:contentTypeDescription="Create a new document." ma:contentTypeScope="" ma:versionID="da2759216466bc3ec804369b15a902a5">
   <xsd:schema xmlns:xsd="http://www.w3.org/2001/XMLSchema" xmlns:xs="http://www.w3.org/2001/XMLSchema" xmlns:p="http://schemas.microsoft.com/office/2006/metadata/properties" xmlns:ns1="http://schemas.microsoft.com/sharepoint/v3" xmlns:ns2="819a213c-e595-4af7-868c-5311d0f07b09" xmlns:ns3="43c4306d-bcae-48a3-b5b4-6245fba36c72" targetNamespace="http://schemas.microsoft.com/office/2006/metadata/properties" ma:root="true" ma:fieldsID="23a203c7101a14e7e286c2f61aba86b7" ns1:_="" ns2:_="" ns3:_="">
     <xsd:import namespace="http://schemas.microsoft.com/sharepoint/v3"/>
@@ -23884,35 +24179,188 @@
 </ct:contentTypeSchema>
 </file>
 
-<file path=customXml/itemProps1.xml><?xml version="1.0" encoding="utf-8"?>
-<ds:datastoreItem xmlns:ds="http://schemas.openxmlformats.org/officeDocument/2006/customXml" ds:itemID="{C64B5808-DACA-4273-92AE-F78AD06EB5C9}">
-  <ds:schemaRefs>
-    <ds:schemaRef ds:uri="http://schemas.microsoft.com/office/2006/metadata/properties"/>
-    <ds:schemaRef ds:uri="http://schemas.microsoft.com/office/infopath/2007/PartnerControls"/>
-    <ds:schemaRef ds:uri="819a213c-e595-4af7-868c-5311d0f07b09"/>
-    <ds:schemaRef ds:uri="http://schemas.microsoft.com/sharepoint/v3"/>
-    <ds:schemaRef ds:uri="43c4306d-bcae-48a3-b5b4-6245fba36c72"/>
-  </ds:schemaRefs>
-</ds:datastoreItem>
+<file path=customXml/item2.xml><?xml version="1.0" encoding="utf-8"?>
+<?mso-contentType ?>
+<spe:Receivers xmlns:spe="http://schemas.microsoft.com/sharepoint/events">
+  <Receiver>
+    <Name>Document ID Generator</Name>
+    <Synchronization>Synchronous</Synchronization>
+    <Type>10001</Type>
+    <SequenceNumber>1000</SequenceNumber>
+    <Url/>
+    <Assembly>Microsoft.Office.DocumentManagement, Version=16.0.0.0, Culture=neutral, PublicKeyToken=71e9bce111e9429c</Assembly>
+    <Class>Microsoft.Office.DocumentManagement.Internal.DocIdHandler</Class>
+    <Data/>
+    <Filter/>
+  </Receiver>
+  <Receiver>
+    <Name>Document ID Generator</Name>
+    <Synchronization>Synchronous</Synchronization>
+    <Type>10002</Type>
+    <SequenceNumber>1001</SequenceNumber>
+    <Url/>
+    <Assembly>Microsoft.Office.DocumentManagement, Version=16.0.0.0, Culture=neutral, PublicKeyToken=71e9bce111e9429c</Assembly>
+    <Class>Microsoft.Office.DocumentManagement.Internal.DocIdHandler</Class>
+    <Data/>
+    <Filter/>
+  </Receiver>
+  <Receiver>
+    <Name>Document ID Generator</Name>
+    <Synchronization>Synchronous</Synchronization>
+    <Type>10004</Type>
+    <SequenceNumber>1002</SequenceNumber>
+    <Url/>
+    <Assembly>Microsoft.Office.DocumentManagement, Version=16.0.0.0, Culture=neutral, PublicKeyToken=71e9bce111e9429c</Assembly>
+    <Class>Microsoft.Office.DocumentManagement.Internal.DocIdHandler</Class>
+    <Data/>
+    <Filter/>
+  </Receiver>
+  <Receiver>
+    <Name>Document ID Generator</Name>
+    <Synchronization>Synchronous</Synchronization>
+    <Type>10006</Type>
+    <SequenceNumber>1003</SequenceNumber>
+    <Url/>
+    <Assembly>Microsoft.Office.DocumentManagement, Version=16.0.0.0, Culture=neutral, PublicKeyToken=71e9bce111e9429c</Assembly>
+    <Class>Microsoft.Office.DocumentManagement.Internal.DocIdHandler</Class>
+    <Data/>
+    <Filter/>
+  </Receiver>
+</spe:Receivers>
 </file>
 
-<file path=customXml/itemProps2.xml><?xml version="1.0" encoding="utf-8"?>
-<ds:datastoreItem xmlns:ds="http://schemas.openxmlformats.org/officeDocument/2006/customXml" ds:itemID="{D5CBC06A-5433-41AC-89E1-93399C4B6D23}">
-  <ds:schemaRefs>
-    <ds:schemaRef ds:uri="http://schemas.microsoft.com/sharepoint/v3/contenttype/forms"/>
-  </ds:schemaRefs>
-</ds:datastoreItem>
+<file path=customXml/item3.xml><?xml version="1.0" encoding="utf-8"?>
+<?mso-contentType ?>
+<FormTemplates xmlns="http://schemas.microsoft.com/sharepoint/v3/contenttype/forms">
+  <Display>DocumentLibraryForm</Display>
+  <Edit>DocumentLibraryForm</Edit>
+  <New>DocumentLibraryForm</New>
+</FormTemplates>
 </file>
 
-<file path=customXml/itemProps3.xml><?xml version="1.0" encoding="utf-8"?>
-<ds:datastoreItem xmlns:ds="http://schemas.openxmlformats.org/officeDocument/2006/customXml" ds:itemID="{1C5A9CCD-8D95-4E29-9BBC-62ED344D200A}">
-  <ds:schemaRefs>
-    <ds:schemaRef ds:uri="http://schemas.microsoft.com/sharepoint/events"/>
-  </ds:schemaRefs>
-</ds:datastoreItem>
+<file path=customXml/item4.xml><?xml version="1.0" encoding="utf-8"?>
+<p:properties xmlns:p="http://schemas.microsoft.com/office/2006/metadata/properties" xmlns:xsi="http://www.w3.org/2001/XMLSchema-instance" xmlns:pc="http://schemas.microsoft.com/office/infopath/2007/PartnerControls">
+  <documentManagement>
+    <Name_x0028_Outlook_x0029_ xmlns="819a213c-e595-4af7-868c-5311d0f07b09">
+      <UserInfo>
+        <DisplayName/>
+        <AccountId xsi:nil="true"/>
+        <AccountType/>
+      </UserInfo>
+    </Name_x0028_Outlook_x0029_>
+    <_ip_UnifiedCompliancePolicyUIAction xmlns="http://schemas.microsoft.com/sharepoint/v3" xsi:nil="true"/>
+    <TaxCatchAll xmlns="43c4306d-bcae-48a3-b5b4-6245fba36c72">
+      <Value>117</Value>
+      <Value>336</Value>
+      <Value>352</Value>
+      <Value>332</Value>
+      <Value>330</Value>
+      <Value>5</Value>
+      <Value>88</Value>
+      <Value>2</Value>
+      <Value>1</Value>
+    </TaxCatchAll>
+    <Project xmlns="819a213c-e595-4af7-868c-5311d0f07b09">Shrike</Project>
+    <b3e0283348f04d719dc2db6c1ad0eab0 xmlns="819a213c-e595-4af7-868c-5311d0f07b09">
+      <Terms xmlns="http://schemas.microsoft.com/office/infopath/2007/PartnerControls"/>
+    </b3e0283348f04d719dc2db6c1ad0eab0>
+    <kf4578e6b9744d06891b013fb9171991 xmlns="819a213c-e595-4af7-868c-5311d0f07b09">
+      <Terms xmlns="http://schemas.microsoft.com/office/infopath/2007/PartnerControls">
+        <TermInfo xmlns="http://schemas.microsoft.com/office/infopath/2007/PartnerControls">
+          <TermName xmlns="http://schemas.microsoft.com/office/infopath/2007/PartnerControls">FCAI</TermName>
+          <TermId xmlns="http://schemas.microsoft.com/office/infopath/2007/PartnerControls">fd9e9f27-4afa-4bd6-9815-b72522a6dee4</TermId>
+        </TermInfo>
+      </Terms>
+    </kf4578e6b9744d06891b013fb9171991>
+    <e7bf107ab2e246c2ae3b25ccb19c4fe7 xmlns="819a213c-e595-4af7-868c-5311d0f07b09">
+      <Terms xmlns="http://schemas.microsoft.com/office/infopath/2007/PartnerControls"/>
+    </e7bf107ab2e246c2ae3b25ccb19c4fe7>
+    <Status xmlns="819a213c-e595-4af7-868c-5311d0f07b09">NA</Status>
+    <k1cd0d7a50e348e5b2cecacdbb53a3ff xmlns="819a213c-e595-4af7-868c-5311d0f07b09">
+      <Terms xmlns="http://schemas.microsoft.com/office/infopath/2007/PartnerControls">
+        <TermInfo xmlns="http://schemas.microsoft.com/office/infopath/2007/PartnerControls">
+          <TermName xmlns="http://schemas.microsoft.com/office/infopath/2007/PartnerControls">NA</TermName>
+          <TermId xmlns="http://schemas.microsoft.com/office/infopath/2007/PartnerControls">6c779868-fdfe-4433-a583-74f72965e832</TermId>
+        </TermInfo>
+      </Terms>
+    </k1cd0d7a50e348e5b2cecacdbb53a3ff>
+    <k4bd3d618c344bb496a0035fa1bfa95e xmlns="819a213c-e595-4af7-868c-5311d0f07b09">
+      <Terms xmlns="http://schemas.microsoft.com/office/infopath/2007/PartnerControls">
+        <TermInfo xmlns="http://schemas.microsoft.com/office/infopath/2007/PartnerControls">
+          <TermName xmlns="http://schemas.microsoft.com/office/infopath/2007/PartnerControls">NA</TermName>
+          <TermId xmlns="http://schemas.microsoft.com/office/infopath/2007/PartnerControls">14e9068e-14f9-49cc-a753-38a742264b27</TermId>
+        </TermInfo>
+      </Terms>
+    </k4bd3d618c344bb496a0035fa1bfa95e>
+    <m3911d227d12438196938f21bccbb829 xmlns="819a213c-e595-4af7-868c-5311d0f07b09">
+      <Terms xmlns="http://schemas.microsoft.com/office/infopath/2007/PartnerControls">
+        <TermInfo xmlns="http://schemas.microsoft.com/office/infopath/2007/PartnerControls">
+          <TermName xmlns="http://schemas.microsoft.com/office/infopath/2007/PartnerControls">Unclassified</TermName>
+          <TermId xmlns="http://schemas.microsoft.com/office/infopath/2007/PartnerControls">0e44ab2e-9e75-4d69-bacf-b9adbba64961</TermId>
+        </TermInfo>
+      </Terms>
+    </m3911d227d12438196938f21bccbb829>
+    <j85403ed819e4ad59bb8aa44734c7278 xmlns="819a213c-e595-4af7-868c-5311d0f07b09">
+      <Terms xmlns="http://schemas.microsoft.com/office/infopath/2007/PartnerControls">
+        <TermInfo xmlns="http://schemas.microsoft.com/office/infopath/2007/PartnerControls">
+          <TermName xmlns="http://schemas.microsoft.com/office/infopath/2007/PartnerControls">NA</TermName>
+          <TermId xmlns="http://schemas.microsoft.com/office/infopath/2007/PartnerControls">c413e2e5-7da6-4fb4-9318-c07a4c95104c</TermId>
+        </TermInfo>
+      </Terms>
+    </j85403ed819e4ad59bb8aa44734c7278>
+    <e41571422c3345b4bda9d3ac979b0442 xmlns="819a213c-e595-4af7-868c-5311d0f07b09">
+      <Terms xmlns="http://schemas.microsoft.com/office/infopath/2007/PartnerControls">
+        <TermInfo xmlns="http://schemas.microsoft.com/office/infopath/2007/PartnerControls">
+          <TermName xmlns="http://schemas.microsoft.com/office/infopath/2007/PartnerControls">Destroy</TermName>
+          <TermId xmlns="http://schemas.microsoft.com/office/infopath/2007/PartnerControls">81460359-14dd-47b4-9102-5fada66d1614</TermId>
+        </TermInfo>
+      </Terms>
+    </e41571422c3345b4bda9d3ac979b0442>
+    <b2c7cbb6fa064dd095a8ebf73878e15c xmlns="819a213c-e595-4af7-868c-5311d0f07b09">
+      <Terms xmlns="http://schemas.microsoft.com/office/infopath/2007/PartnerControls">
+        <TermInfo xmlns="http://schemas.microsoft.com/office/infopath/2007/PartnerControls">
+          <TermName xmlns="http://schemas.microsoft.com/office/infopath/2007/PartnerControls">D</TermName>
+          <TermId xmlns="http://schemas.microsoft.com/office/infopath/2007/PartnerControls">e66b2925-d207-445d-a7ac-7bf5587a61c3</TermId>
+        </TermInfo>
+      </Terms>
+    </b2c7cbb6fa064dd095a8ebf73878e15c>
+    <n050dff107b041e7a8136cabb03c9f16 xmlns="819a213c-e595-4af7-868c-5311d0f07b09">
+      <Terms xmlns="http://schemas.microsoft.com/office/infopath/2007/PartnerControls"/>
+    </n050dff107b041e7a8136cabb03c9f16>
+    <dbcc5996da9743a2aff52ccb96daf316 xmlns="819a213c-e595-4af7-868c-5311d0f07b09">
+      <Terms xmlns="http://schemas.microsoft.com/office/infopath/2007/PartnerControls"/>
+    </dbcc5996da9743a2aff52ccb96daf316>
+    <_ip_UnifiedCompliancePolicyProperties xmlns="http://schemas.microsoft.com/sharepoint/v3" xsi:nil="true"/>
+    <Comments xmlns="819a213c-e595-4af7-868c-5311d0f07b09" xsi:nil="true"/>
+    <_dlc_DocIdPersistId xmlns="43c4306d-bcae-48a3-b5b4-6245fba36c72" xsi:nil="true"/>
+    <_dlc_DocIdUrl xmlns="43c4306d-bcae-48a3-b5b4-6245fba36c72">
+      <Url>https://armyeitaas.sharepoint-mil.us/teams/AI2CKMDevelopmentTeam/_layouts/15/DocIdRedir.aspx?ID=PNCAVZZWCJMJ-719779062-26496</Url>
+      <Description>PNCAVZZWCJMJ-719779062-26496</Description>
+    </_dlc_DocIdUrl>
+    <Teams xmlns="819a213c-e595-4af7-868c-5311d0f07b09">NA</Teams>
+    <lcf76f155ced4ddcb4097134ff3c332f xmlns="819a213c-e595-4af7-868c-5311d0f07b09">
+      <Terms xmlns="http://schemas.microsoft.com/office/infopath/2007/PartnerControls"/>
+    </lcf76f155ced4ddcb4097134ff3c332f>
+    <kf187aa08ef840c0be306c2b7cf181cc xmlns="819a213c-e595-4af7-868c-5311d0f07b09">
+      <Terms xmlns="http://schemas.microsoft.com/office/infopath/2007/PartnerControls"/>
+    </kf187aa08ef840c0be306c2b7cf181cc>
+    <k8ed72fc0ac74230bc2bce9a30aa3ff1 xmlns="819a213c-e595-4af7-868c-5311d0f07b09">
+      <Terms xmlns="http://schemas.microsoft.com/office/infopath/2007/PartnerControls"/>
+    </k8ed72fc0ac74230bc2bce9a30aa3ff1>
+    <j3cec2dc15da4ea9ae4c2914aab734b8 xmlns="819a213c-e595-4af7-868c-5311d0f07b09">
+      <Terms xmlns="http://schemas.microsoft.com/office/infopath/2007/PartnerControls">
+        <TermInfo xmlns="http://schemas.microsoft.com/office/infopath/2007/PartnerControls">
+          <TermName xmlns="http://schemas.microsoft.com/office/infopath/2007/PartnerControls">Unofficial</TermName>
+          <TermId xmlns="http://schemas.microsoft.com/office/infopath/2007/PartnerControls">fb72a3e1-cd07-4e90-8aa1-1e35bcf7448f</TermId>
+        </TermInfo>
+      </Terms>
+    </j3cec2dc15da4ea9ae4c2914aab734b8>
+    <_dlc_DocId xmlns="43c4306d-bcae-48a3-b5b4-6245fba36c72">PNCAVZZWCJMJ-719779062-26496</_dlc_DocId>
+  </documentManagement>
+</p:properties>
 </file>
 
-<file path=customXml/itemProps4.xml><?xml version="1.0" encoding="utf-8"?>
+<file path=customXml/itemProps1.xml><?xml version="1.0" encoding="utf-8"?>
 <ds:datastoreItem xmlns:ds="http://schemas.openxmlformats.org/officeDocument/2006/customXml" ds:itemID="{8F325A96-F9CD-4C1F-BC68-5ED8156DC1C7}">
   <ds:schemaRefs>
     <ds:schemaRef ds:uri="http://schemas.microsoft.com/office/2006/metadata/contentType"/>
@@ -23932,6 +24380,34 @@
 </ds:datastoreItem>
 </file>
 
+<file path=customXml/itemProps2.xml><?xml version="1.0" encoding="utf-8"?>
+<ds:datastoreItem xmlns:ds="http://schemas.openxmlformats.org/officeDocument/2006/customXml" ds:itemID="{1C5A9CCD-8D95-4E29-9BBC-62ED344D200A}">
+  <ds:schemaRefs>
+    <ds:schemaRef ds:uri="http://schemas.microsoft.com/sharepoint/events"/>
+  </ds:schemaRefs>
+</ds:datastoreItem>
+</file>
+
+<file path=customXml/itemProps3.xml><?xml version="1.0" encoding="utf-8"?>
+<ds:datastoreItem xmlns:ds="http://schemas.openxmlformats.org/officeDocument/2006/customXml" ds:itemID="{D5CBC06A-5433-41AC-89E1-93399C4B6D23}">
+  <ds:schemaRefs>
+    <ds:schemaRef ds:uri="http://schemas.microsoft.com/sharepoint/v3/contenttype/forms"/>
+  </ds:schemaRefs>
+</ds:datastoreItem>
+</file>
+
+<file path=customXml/itemProps4.xml><?xml version="1.0" encoding="utf-8"?>
+<ds:datastoreItem xmlns:ds="http://schemas.openxmlformats.org/officeDocument/2006/customXml" ds:itemID="{C64B5808-DACA-4273-92AE-F78AD06EB5C9}">
+  <ds:schemaRefs>
+    <ds:schemaRef ds:uri="http://schemas.microsoft.com/office/2006/metadata/properties"/>
+    <ds:schemaRef ds:uri="http://schemas.microsoft.com/office/infopath/2007/PartnerControls"/>
+    <ds:schemaRef ds:uri="819a213c-e595-4af7-868c-5311d0f07b09"/>
+    <ds:schemaRef ds:uri="http://schemas.microsoft.com/sharepoint/v3"/>
+    <ds:schemaRef ds:uri="43c4306d-bcae-48a3-b5b4-6245fba36c72"/>
+  </ds:schemaRefs>
+</ds:datastoreItem>
+</file>
+
 <file path=docMetadata/LabelInfo.xml><?xml version="1.0" encoding="utf-8"?>
 <clbl:labelList xmlns:clbl="http://schemas.microsoft.com/office/2020/mipLabelMetadata">
   <clbl:label id="{554eecc5-e26c-4620-b240-5a8bb326c33d}" enabled="1" method="Privileged" siteId="{fae6d70f-954b-4811-92b6-0530d6f84c43}" contentBits="0" removed="0"/>

</xml_diff>